<commit_message>
Publish protected live voice demo and captioned recording
</commit_message>
<xml_diff>
--- a/presentation/QuoteReady.pptx
+++ b/presentation/QuoteReady.pptx
@@ -3620,7 +3620,7 @@
                 <a:ea typeface="Aptos" pitchFamily="34" charset="-122"/>
                 <a:cs typeface="Aptos" pitchFamily="34" charset="-120"/>
               </a:rPr>
-              <a:t>Five-minute session cap.</a:t>
+              <a:t>Three-minute hosted session cap.</a:t>
             </a:r>
             <a:endParaRPr lang="en-US" sz="1900" dirty="0"/>
           </a:p>
@@ -4143,7 +4143,7 @@
                 <a:ea typeface="Aptos" pitchFamily="34" charset="-122"/>
                 <a:cs typeface="Aptos" pitchFamily="34" charset="-120"/>
               </a:rPr>
-              <a:t>Live API capture and correction</a:t>
+              <a:t>Live browser capture and correction</a:t>
             </a:r>
             <a:endParaRPr lang="en-US" sz="3800" dirty="0"/>
           </a:p>
@@ -4269,7 +4269,7 @@
                 <a:ea typeface="Aptos" pitchFamily="34" charset="-122"/>
                 <a:cs typeface="Aptos" pitchFamily="34" charset="-120"/>
               </a:rPr>
-              <a:t>22 local tests</a:t>
+              <a:t>26 local tests</a:t>
             </a:r>
             <a:endParaRPr lang="en-US" sz="2100" dirty="0"/>
           </a:p>
@@ -4569,7 +4569,7 @@
                 <a:ea typeface="Aptos" pitchFamily="34" charset="-122"/>
                 <a:cs typeface="Aptos" pitchFamily="34" charset="-120"/>
               </a:rPr>
-              <a:t>Synthetic speech is API integration evidence. Browser microphone and interruption testing remain pending.</a:t>
+              <a:t>Recorded from the public live app. Microphone connection also checked; broader speaker testing is future work.</a:t>
             </a:r>
             <a:endParaRPr lang="en-US" sz="1600" dirty="0"/>
           </a:p>
@@ -5034,7 +5034,7 @@
                 <a:ea typeface="Aptos" pitchFamily="34" charset="-122"/>
                 <a:cs typeface="Aptos" pitchFamily="34" charset="-120"/>
               </a:rPr>
-              <a:t>Still to verify</a:t>
+              <a:t>Next evaluation</a:t>
             </a:r>
             <a:endParaRPr lang="en-US" sz="2100" dirty="0"/>
           </a:p>
@@ -5075,7 +5075,7 @@
                 <a:ea typeface="Aptos" pitchFamily="34" charset="-122"/>
                 <a:cs typeface="Aptos" pitchFamily="34" charset="-120"/>
               </a:rPr>
-              <a:t>Real microphone and interruption demo.</a:t>
+              <a:t>More accents and noisy microphones.</a:t>
             </a:r>
             <a:endParaRPr lang="en-US" sz="1900" dirty="0"/>
           </a:p>
@@ -5092,7 +5092,7 @@
                 <a:ea typeface="Aptos" pitchFamily="34" charset="-122"/>
                 <a:cs typeface="Aptos" pitchFamily="34" charset="-120"/>
               </a:rPr>
-              <a:t>Secured public live voice hosting.</a:t>
+              <a:t>Service-business usability feedback.</a:t>
             </a:r>
             <a:endParaRPr lang="en-US" sz="1900" dirty="0"/>
           </a:p>
@@ -5109,7 +5109,7 @@
                 <a:ea typeface="Aptos" pitchFamily="34" charset="-122"/>
                 <a:cs typeface="Aptos" pitchFamily="34" charset="-120"/>
               </a:rPr>
-              <a:t>Final entry and any award.</a:t>
+              <a:t>Optional business-side delivery.</a:t>
             </a:r>
             <a:endParaRPr lang="en-US" sz="1900" dirty="0"/>
           </a:p>

</xml_diff>